<commit_message>
Force light theme for the public dashboard and add the live URL
Streamlit follows the viewer's dark preference by default, which made the light KPI cards unreadable. Set the base theme to light, split runtime and document dependencies, and link the deployed app from the README and report.

🤖 Generated with Codebuff
Co-Authored-By: Codebuff <noreply@codebuff.com>
</commit_message>
<xml_diff>
--- a/reports/presentation/MILLING_CEP_SLIDES.pptx
+++ b/reports/presentation/MILLING_CEP_SLIDES.pptx
@@ -6759,8 +6759,8 @@
         </p:nvSpPr>
         <p:spPr>
           <a:xfrm>
-            <a:off x="777240" y="5897880"/>
-            <a:ext cx="10698480" cy="457200"/>
+            <a:off x="777240" y="5742432"/>
+            <a:ext cx="10698480" cy="320040"/>
           </a:xfrm>
           <a:prstGeom prst="rect">
             <a:avLst/>
@@ -6779,7 +6779,46 @@
               </a:lnSpc>
             </a:pPr>
             <a:r>
-              <a:rPr sz="1100" b="0">
+              <a:rPr sz="1050" b="1">
+                <a:solidFill>
+                  <a:srgbClr val="9FC6DE"/>
+                </a:solidFill>
+                <a:latin typeface="Arial"/>
+              </a:rPr>
+              <a:t>Live dashboard:  milling-cep-iguwxgwerngzavkpz2aguj.streamlit.app</a:t>
+            </a:r>
+          </a:p>
+        </p:txBody>
+      </p:sp>
+      <p:sp>
+        <p:nvSpPr>
+          <p:cNvPr id="15" name="TextBox 14"/>
+          <p:cNvSpPr txBox="1"/>
+          <p:nvPr/>
+        </p:nvSpPr>
+        <p:spPr>
+          <a:xfrm>
+            <a:off x="777240" y="6080760"/>
+            <a:ext cx="10698480" cy="320040"/>
+          </a:xfrm>
+          <a:prstGeom prst="rect">
+            <a:avLst/>
+          </a:prstGeom>
+          <a:noFill/>
+        </p:spPr>
+        <p:txBody>
+          <a:bodyPr wrap="square" anchor="t" lIns="0" rIns="0" tIns="0" bIns="0">
+            <a:spAutoFit/>
+          </a:bodyPr>
+          <a:lstStyle/>
+          <a:p>
+            <a:pPr algn="l">
+              <a:lnSpc>
+                <a:spcPct val="100000"/>
+              </a:lnSpc>
+            </a:pPr>
+            <a:r>
+              <a:rPr sz="1050" b="0">
                 <a:solidFill>
                   <a:srgbClr val="B7CBD9"/>
                 </a:solidFill>

</xml_diff>